<commit_message>
✨ Bold slide titles and remove title rule in all slide formats
Regenerate slide and example outputs.
</commit_message>
<xml_diff>
--- a/_extensions/slides-pptx/template.pptx
+++ b/_extensions/slides-pptx/template.pptx
@@ -1107,30 +1107,6 @@
       </p:sp>
       <p:sp>
         <p:nvSpPr>
-          <p:cNvPr id="99" name="Header Line"/>
-          <p:cNvSpPr>
-            <a:spLocks noGrp="1"/>
-          </p:cNvSpPr>
-          <p:nvPr/>
-        </p:nvSpPr>
-        <p:spPr>
-          <a:xfrm>
-            <a:off x="0" y="914400"/>
-            <a:ext cx="12191695" cy="25400"/>
-          </a:xfrm>
-          <a:prstGeom prst="rect">
-            <a:avLst/>
-          </a:prstGeom>
-          <a:solidFill>
-            <a:srgbClr val="179299"/>
-          </a:solidFill>
-          <a:ln>
-            <a:noFill/>
-          </a:ln>
-        </p:spPr>
-      </p:sp>
-      <p:sp>
-        <p:nvSpPr>
           <p:cNvPr id="98" name="Slide Number Box"/>
           <p:cNvSpPr txBox="1"/>
           <p:nvPr/>
@@ -1354,30 +1330,6 @@
       </p:sp>
       <p:sp>
         <p:nvSpPr>
-          <p:cNvPr id="99" name="Header Line"/>
-          <p:cNvSpPr>
-            <a:spLocks noGrp="1"/>
-          </p:cNvSpPr>
-          <p:nvPr/>
-        </p:nvSpPr>
-        <p:spPr>
-          <a:xfrm>
-            <a:off x="0" y="914400"/>
-            <a:ext cx="12191695" cy="25400"/>
-          </a:xfrm>
-          <a:prstGeom prst="rect">
-            <a:avLst/>
-          </a:prstGeom>
-          <a:solidFill>
-            <a:srgbClr val="179299"/>
-          </a:solidFill>
-          <a:ln>
-            <a:noFill/>
-          </a:ln>
-        </p:spPr>
-      </p:sp>
-      <p:sp>
-        <p:nvSpPr>
           <p:cNvPr id="98" name="Slide Number Box"/>
           <p:cNvSpPr txBox="1"/>
           <p:nvPr/>
@@ -1601,30 +1553,6 @@
       </p:sp>
       <p:sp>
         <p:nvSpPr>
-          <p:cNvPr id="99" name="Header Line"/>
-          <p:cNvSpPr>
-            <a:spLocks noGrp="1"/>
-          </p:cNvSpPr>
-          <p:nvPr/>
-        </p:nvSpPr>
-        <p:spPr>
-          <a:xfrm>
-            <a:off x="0" y="914400"/>
-            <a:ext cx="12191695" cy="25400"/>
-          </a:xfrm>
-          <a:prstGeom prst="rect">
-            <a:avLst/>
-          </a:prstGeom>
-          <a:solidFill>
-            <a:srgbClr val="179299"/>
-          </a:solidFill>
-          <a:ln>
-            <a:noFill/>
-          </a:ln>
-        </p:spPr>
-      </p:sp>
-      <p:sp>
-        <p:nvSpPr>
           <p:cNvPr id="98" name="Slide Number Box"/>
           <p:cNvSpPr txBox="1"/>
           <p:nvPr/>
@@ -1718,7 +1646,7 @@
           <a:bodyPr anchor="ctr" lIns="182880" tIns="182880" rIns="182880" bIns="182880"/>
           <a:lstStyle>
             <a:lvl1pPr algn="l">
-              <a:defRPr sz="3000">
+              <a:defRPr sz="3000" b="0">
                 <a:latin typeface="Fira Sans"/>
               </a:defRPr>
             </a:lvl1pPr>
@@ -2297,30 +2225,6 @@
       </p:sp>
       <p:sp>
         <p:nvSpPr>
-          <p:cNvPr id="99" name="Header Line"/>
-          <p:cNvSpPr>
-            <a:spLocks noGrp="1"/>
-          </p:cNvSpPr>
-          <p:nvPr/>
-        </p:nvSpPr>
-        <p:spPr>
-          <a:xfrm>
-            <a:off x="0" y="914400"/>
-            <a:ext cx="12191695" cy="25400"/>
-          </a:xfrm>
-          <a:prstGeom prst="rect">
-            <a:avLst/>
-          </a:prstGeom>
-          <a:solidFill>
-            <a:srgbClr val="179299"/>
-          </a:solidFill>
-          <a:ln>
-            <a:noFill/>
-          </a:ln>
-        </p:spPr>
-      </p:sp>
-      <p:sp>
-        <p:nvSpPr>
           <p:cNvPr id="98" name="Slide Number Box"/>
           <p:cNvSpPr txBox="1"/>
           <p:nvPr/>
@@ -2859,30 +2763,6 @@
       </p:sp>
       <p:sp>
         <p:nvSpPr>
-          <p:cNvPr id="99" name="Header Line"/>
-          <p:cNvSpPr>
-            <a:spLocks noGrp="1"/>
-          </p:cNvSpPr>
-          <p:nvPr/>
-        </p:nvSpPr>
-        <p:spPr>
-          <a:xfrm>
-            <a:off x="0" y="914400"/>
-            <a:ext cx="12191695" cy="25400"/>
-          </a:xfrm>
-          <a:prstGeom prst="rect">
-            <a:avLst/>
-          </a:prstGeom>
-          <a:solidFill>
-            <a:srgbClr val="179299"/>
-          </a:solidFill>
-          <a:ln>
-            <a:noFill/>
-          </a:ln>
-        </p:spPr>
-      </p:sp>
-      <p:sp>
-        <p:nvSpPr>
           <p:cNvPr id="98" name="Slide Number Box"/>
           <p:cNvSpPr txBox="1"/>
           <p:nvPr/>
@@ -3050,30 +2930,6 @@
       </p:sp>
       <p:sp>
         <p:nvSpPr>
-          <p:cNvPr id="99" name="Header Line"/>
-          <p:cNvSpPr>
-            <a:spLocks noGrp="1"/>
-          </p:cNvSpPr>
-          <p:nvPr/>
-        </p:nvSpPr>
-        <p:spPr>
-          <a:xfrm>
-            <a:off x="0" y="914400"/>
-            <a:ext cx="12191695" cy="25400"/>
-          </a:xfrm>
-          <a:prstGeom prst="rect">
-            <a:avLst/>
-          </a:prstGeom>
-          <a:solidFill>
-            <a:srgbClr val="179299"/>
-          </a:solidFill>
-          <a:ln>
-            <a:noFill/>
-          </a:ln>
-        </p:spPr>
-      </p:sp>
-      <p:sp>
-        <p:nvSpPr>
           <p:cNvPr id="98" name="Slide Number Box"/>
           <p:cNvSpPr txBox="1"/>
           <p:nvPr/>
@@ -3563,30 +3419,6 @@
             <a:endParaRPr lang="en-US"/>
           </a:p>
         </p:txBody>
-      </p:sp>
-      <p:sp>
-        <p:nvSpPr>
-          <p:cNvPr id="99" name="Header Line"/>
-          <p:cNvSpPr>
-            <a:spLocks noGrp="1"/>
-          </p:cNvSpPr>
-          <p:nvPr/>
-        </p:nvSpPr>
-        <p:spPr>
-          <a:xfrm>
-            <a:off x="0" y="914400"/>
-            <a:ext cx="12191695" cy="25400"/>
-          </a:xfrm>
-          <a:prstGeom prst="rect">
-            <a:avLst/>
-          </a:prstGeom>
-          <a:solidFill>
-            <a:srgbClr val="179299"/>
-          </a:solidFill>
-          <a:ln>
-            <a:noFill/>
-          </a:ln>
-        </p:spPr>
       </p:sp>
       <p:sp>
         <p:nvSpPr>
@@ -4246,7 +4078,7 @@
           <a:spcPct val="0"/>
         </a:spcBef>
         <a:buNone/>
-        <a:defRPr sz="2600" kern="1200">
+        <a:defRPr sz="2600" b="1" kern="1200">
           <a:solidFill>
             <a:schemeClr val="tx1"/>
           </a:solidFill>

</xml_diff>